<commit_message>
made changes to the evol website
</commit_message>
<xml_diff>
--- a/teaching/CS472/Timetable/OOD-V2.pptx
+++ b/teaching/CS472/Timetable/OOD-V2.pptx
@@ -17598,12 +17598,14 @@
           </a:xfrm>
         </p:spPr>
         <p:txBody>
-          <a:bodyPr/>
-          <a:lstStyle/>
-          <a:p>
-            <a:r>
-              <a:rPr lang="en-GB" b="1" dirty="0"/>
-              <a:t>From Diagram to Implementation</a:t>
+          <a:bodyPr>
+            <a:normAutofit/>
+          </a:bodyPr>
+          <a:lstStyle/>
+          <a:p>
+            <a:r>
+              <a:rPr lang="en-GB" sz="4000" b="1" dirty="0"/>
+              <a:t>From Diagram to Java: Files &amp; Methods</a:t>
             </a:r>
           </a:p>
         </p:txBody>
@@ -19229,12 +19231,14 @@
           </a:xfrm>
         </p:spPr>
         <p:txBody>
-          <a:bodyPr/>
-          <a:lstStyle/>
-          <a:p>
-            <a:r>
-              <a:rPr lang="en-GB" b="1" dirty="0"/>
-              <a:t>From Diagram to Implementation</a:t>
+          <a:bodyPr>
+            <a:normAutofit/>
+          </a:bodyPr>
+          <a:lstStyle/>
+          <a:p>
+            <a:r>
+              <a:rPr lang="en-GB" sz="4000" b="1" dirty="0"/>
+              <a:t>From Diagram to Code: Three Classes in Order</a:t>
             </a:r>
           </a:p>
         </p:txBody>
@@ -23127,6 +23131,12 @@
           <a:p>
             <a:r>
               <a:rPr lang="en-BE" dirty="0"/>
+              <a:t>The Discord communication and meeting minutes are both assessed</a:t>
+            </a:r>
+          </a:p>
+          <a:p>
+            <a:r>
+              <a:rPr lang="en-BE" dirty="0"/>
               <a:t>Lab 2 is dues 9/18 </a:t>
             </a:r>
           </a:p>
@@ -27055,13 +27065,16 @@
           </a:xfrm>
         </p:spPr>
         <p:txBody>
-          <a:bodyPr/>
-          <a:lstStyle/>
-          <a:p>
-            <a:r>
-              <a:rPr lang="en-BE" dirty="0"/>
-              <a:t>Project</a:t>
-            </a:r>
+          <a:bodyPr>
+            <a:normAutofit/>
+          </a:bodyPr>
+          <a:lstStyle/>
+          <a:p>
+            <a:r>
+              <a:rPr lang="en-GB" sz="4000" b="1" dirty="0"/>
+              <a:t>How Your Design Discipline Is Graded</a:t>
+            </a:r>
+            <a:endParaRPr lang="en-BE" sz="4000" b="1" dirty="0"/>
           </a:p>
         </p:txBody>
       </p:sp>
@@ -27088,17 +27101,19 @@
           </a:xfrm>
         </p:spPr>
         <p:txBody>
-          <a:bodyPr/>
-          <a:lstStyle/>
-          <a:p>
-            <a:r>
-              <a:rPr lang="en-BE" dirty="0"/>
-              <a:t>For Design Portfolio II and III</a:t>
+          <a:bodyPr>
+            <a:normAutofit/>
+          </a:bodyPr>
+          <a:lstStyle/>
+          <a:p>
+            <a:r>
+              <a:rPr lang="en-GB" sz="2400" dirty="0"/>
+              <a:t>Design Portfolios II &amp; III — every major feature needs diagrams linked to its PR.</a:t>
             </a:r>
             <a:br>
-              <a:rPr lang="en-GB" dirty="0"/>
+              <a:rPr lang="en-GB" sz="2400" dirty="0"/>
             </a:br>
-            <a:endParaRPr lang="en-BE" dirty="0"/>
+            <a:endParaRPr lang="en-BE" sz="2400" dirty="0"/>
           </a:p>
         </p:txBody>
       </p:sp>
@@ -27727,9 +27742,9 @@
                 <a:solidFill>
                   <a:srgbClr val="111111"/>
                 </a:solidFill>
-                <a:latin typeface="Calibri"/>
+                <a:latin typeface="Arial" panose="020B0604020202020204" pitchFamily="34" charset="0"/>
                 <a:ea typeface="Calibri"/>
-                <a:cs typeface="Calibri"/>
+                <a:cs typeface="Arial" panose="020B0604020202020204" pitchFamily="34" charset="0"/>
               </a:rPr>
               <a:t>Connect requirements, design decisions, implementation, tests, and CI.</a:t>
             </a:r>
@@ -27755,9 +27770,9 @@
                 <a:solidFill>
                   <a:srgbClr val="111111"/>
                 </a:solidFill>
-                <a:latin typeface="Calibri"/>
+                <a:latin typeface="Arial" panose="020B0604020202020204" pitchFamily="34" charset="0"/>
                 <a:ea typeface="Calibri"/>
-                <a:cs typeface="Calibri"/>
+                <a:cs typeface="Arial" panose="020B0604020202020204" pitchFamily="34" charset="0"/>
               </a:rPr>
               <a:t>Choose a class diagram for structural changes and a sequence diagram for interaction changes.</a:t>
             </a:r>
@@ -27783,9 +27798,9 @@
                 <a:solidFill>
                   <a:srgbClr val="111111"/>
                 </a:solidFill>
-                <a:latin typeface="Calibri"/>
+                <a:latin typeface="Arial" panose="020B0604020202020204" pitchFamily="34" charset="0"/>
                 <a:ea typeface="Calibri"/>
-                <a:cs typeface="Calibri"/>
+                <a:cs typeface="Arial" panose="020B0604020202020204" pitchFamily="34" charset="0"/>
               </a:rPr>
               <a:t>Keep each pull request focused on one coherent design and implementation increment.</a:t>
             </a:r>
@@ -27811,9 +27826,9 @@
                 <a:solidFill>
                   <a:srgbClr val="111111"/>
                 </a:solidFill>
-                <a:latin typeface="Calibri"/>
+                <a:latin typeface="Arial" panose="020B0604020202020204" pitchFamily="34" charset="0"/>
                 <a:ea typeface="Calibri"/>
-                <a:cs typeface="Calibri"/>
+                <a:cs typeface="Arial" panose="020B0604020202020204" pitchFamily="34" charset="0"/>
               </a:rPr>
               <a:t>Review whether the diagram, code, and tests describe the same system behavior.</a:t>
             </a:r>
@@ -27864,13 +27879,13 @@
               </a:defRPr>
             </a:pPr>
             <a:r>
-              <a:rPr sz="1875" b="1">
+              <a:rPr sz="1875" b="1" dirty="0">
                 <a:solidFill>
                   <a:srgbClr val="1F5B42"/>
                 </a:solidFill>
-                <a:latin typeface="Calibri"/>
+                <a:latin typeface="Arial" panose="020B0604020202020204" pitchFamily="34" charset="0"/>
                 <a:ea typeface="Calibri"/>
-                <a:cs typeface="Calibri"/>
+                <a:cs typeface="Arial" panose="020B0604020202020204" pitchFamily="34" charset="0"/>
               </a:rPr>
               <a:t>Make design changes visible and reviewable before they reach the main branch.</a:t>
             </a:r>

</xml_diff>